<commit_message>
Module 05: re-recorded English walkthrough, English advanced film fix, code-lab note in the pack README
Co-Authored-By: Claude Opus 5.5 (1M context) <noreply@anthropic.com>
Claude-Session: https://claude.ai/code/session_01YUzBMRXLXxqyUWCr3UD4wg
</commit_message>
<xml_diff>
--- a/site/slides/m05-label-propagation/en/m05-label-propagation-en.pptx
+++ b/site/slides/m05-label-propagation/en/m05-label-propagation-en.pptx
@@ -4490,8 +4490,8 @@
         </p:nvSpPr>
         <p:spPr>
           <a:xfrm>
-            <a:off x="9517380" y="377952"/>
-            <a:ext cx="2148840" cy="205740"/>
+            <a:off x="9682480" y="377952"/>
+            <a:ext cx="1983739" cy="205740"/>
           </a:xfrm>
           <a:prstGeom prst="rect">
             <a:avLst/>
@@ -4513,7 +4513,7 @@
                 <a:latin typeface="Noto Sans SC"/>
                 <a:ea typeface="Noto Sans SC"/>
               </a:rPr>
-              <a:t>Film “The essentials” 00:00</a:t>
+              <a:t>Film "The essentials" 00:00</a:t>
             </a:r>
           </a:p>
         </p:txBody>
@@ -4923,8 +4923,8 @@
         </p:nvSpPr>
         <p:spPr>
           <a:xfrm>
-            <a:off x="9517380" y="377952"/>
-            <a:ext cx="2148840" cy="205740"/>
+            <a:off x="9682480" y="377952"/>
+            <a:ext cx="1983739" cy="205740"/>
           </a:xfrm>
           <a:prstGeom prst="rect">
             <a:avLst/>
@@ -4946,7 +4946,7 @@
                 <a:latin typeface="Noto Sans SC"/>
                 <a:ea typeface="Noto Sans SC"/>
               </a:rPr>
-              <a:t>Film “The essentials” 01:31</a:t>
+              <a:t>Film "The essentials" 01:31</a:t>
             </a:r>
           </a:p>
         </p:txBody>
@@ -7834,8 +7834,8 @@
         </p:nvSpPr>
         <p:spPr>
           <a:xfrm>
-            <a:off x="8310880" y="377952"/>
-            <a:ext cx="3355340" cy="205740"/>
+            <a:off x="8475980" y="377952"/>
+            <a:ext cx="3190240" cy="205740"/>
           </a:xfrm>
           <a:prstGeom prst="rect">
             <a:avLst/>
@@ -7857,7 +7857,7 @@
                 <a:latin typeface="Noto Sans SC"/>
                 <a:ea typeface="Noto Sans SC"/>
               </a:rPr>
-              <a:t>Film “Where Do Clusters Come From?” 00:34</a:t>
+              <a:t>Film "Where Do Clusters Come From?" 00:34</a:t>
             </a:r>
           </a:p>
         </p:txBody>
@@ -12102,8 +12102,8 @@
         </p:nvSpPr>
         <p:spPr>
           <a:xfrm>
-            <a:off x="8310880" y="377952"/>
-            <a:ext cx="3355340" cy="205740"/>
+            <a:off x="8475980" y="377952"/>
+            <a:ext cx="3190240" cy="205740"/>
           </a:xfrm>
           <a:prstGeom prst="rect">
             <a:avLst/>
@@ -12125,7 +12125,7 @@
                 <a:latin typeface="Noto Sans SC"/>
                 <a:ea typeface="Noto Sans SC"/>
               </a:rPr>
-              <a:t>Film “Where Do Clusters Come From?” 00:51</a:t>
+              <a:t>Film "Where Do Clusters Come From?" 00:51</a:t>
             </a:r>
           </a:p>
         </p:txBody>
@@ -15995,8 +15995,8 @@
         </p:nvSpPr>
         <p:spPr>
           <a:xfrm>
-            <a:off x="9517380" y="377952"/>
-            <a:ext cx="2148840" cy="205740"/>
+            <a:off x="9682480" y="377952"/>
+            <a:ext cx="1983739" cy="205740"/>
           </a:xfrm>
           <a:prstGeom prst="rect">
             <a:avLst/>
@@ -16018,7 +16018,7 @@
                 <a:latin typeface="Noto Sans SC"/>
                 <a:ea typeface="Noto Sans SC"/>
               </a:rPr>
-              <a:t>Film “The essentials” 00:28</a:t>
+              <a:t>Film "The essentials" 00:28</a:t>
             </a:r>
           </a:p>
         </p:txBody>
@@ -18154,8 +18154,8 @@
         </p:nvSpPr>
         <p:spPr>
           <a:xfrm>
-            <a:off x="9517380" y="377952"/>
-            <a:ext cx="2148840" cy="205740"/>
+            <a:off x="9682480" y="377952"/>
+            <a:ext cx="1983739" cy="205740"/>
           </a:xfrm>
           <a:prstGeom prst="rect">
             <a:avLst/>
@@ -18177,7 +18177,7 @@
                 <a:latin typeface="Noto Sans SC"/>
                 <a:ea typeface="Noto Sans SC"/>
               </a:rPr>
-              <a:t>Film “The essentials” 00:41</a:t>
+              <a:t>Film "The essentials" 00:41</a:t>
             </a:r>
           </a:p>
         </p:txBody>
@@ -20920,8 +20920,8 @@
         </p:nvSpPr>
         <p:spPr>
           <a:xfrm>
-            <a:off x="9517380" y="377952"/>
-            <a:ext cx="2148840" cy="205740"/>
+            <a:off x="9682480" y="377952"/>
+            <a:ext cx="1983739" cy="205740"/>
           </a:xfrm>
           <a:prstGeom prst="rect">
             <a:avLst/>
@@ -20943,7 +20943,7 @@
                 <a:latin typeface="Noto Sans SC"/>
                 <a:ea typeface="Noto Sans SC"/>
               </a:rPr>
-              <a:t>Film “The essentials” 00:59</a:t>
+              <a:t>Film "The essentials" 00:59</a:t>
             </a:r>
           </a:p>
         </p:txBody>
@@ -22636,8 +22636,8 @@
         </p:nvSpPr>
         <p:spPr>
           <a:xfrm>
-            <a:off x="9517380" y="377952"/>
-            <a:ext cx="2148840" cy="205740"/>
+            <a:off x="9682480" y="377952"/>
+            <a:ext cx="1983739" cy="205740"/>
           </a:xfrm>
           <a:prstGeom prst="rect">
             <a:avLst/>
@@ -22659,7 +22659,7 @@
                 <a:latin typeface="Noto Sans SC"/>
                 <a:ea typeface="Noto Sans SC"/>
               </a:rPr>
-              <a:t>Film “The essentials” 01:48</a:t>
+              <a:t>Film "The essentials" 01:48</a:t>
             </a:r>
           </a:p>
         </p:txBody>
@@ -25054,8 +25054,8 @@
         </p:nvSpPr>
         <p:spPr>
           <a:xfrm>
-            <a:off x="9517380" y="377952"/>
-            <a:ext cx="2148840" cy="205740"/>
+            <a:off x="9682480" y="377952"/>
+            <a:ext cx="1983739" cy="205740"/>
           </a:xfrm>
           <a:prstGeom prst="rect">
             <a:avLst/>
@@ -25077,7 +25077,7 @@
                 <a:latin typeface="Noto Sans SC"/>
                 <a:ea typeface="Noto Sans SC"/>
               </a:rPr>
-              <a:t>Film “The essentials” 02:03</a:t>
+              <a:t>Film "The essentials" 02:03</a:t>
             </a:r>
           </a:p>
         </p:txBody>
@@ -26881,8 +26881,8 @@
         </p:nvSpPr>
         <p:spPr>
           <a:xfrm>
-            <a:off x="8310880" y="377952"/>
-            <a:ext cx="3355340" cy="205740"/>
+            <a:off x="8475980" y="377952"/>
+            <a:ext cx="3190240" cy="205740"/>
           </a:xfrm>
           <a:prstGeom prst="rect">
             <a:avLst/>
@@ -26904,7 +26904,7 @@
                 <a:latin typeface="Noto Sans SC"/>
                 <a:ea typeface="Noto Sans SC"/>
               </a:rPr>
-              <a:t>Film “Where Do Clusters Come From?” 05:09</a:t>
+              <a:t>Film "Where Do Clusters Come From?" 05:09</a:t>
             </a:r>
           </a:p>
         </p:txBody>

</xml_diff>